<commit_message>
docs: expand persistence and database details in TFI presentations
</commit_message>
<xml_diff>
--- a/Etapas/teoria/metodologia/presentacion_cooperadora.pptx
+++ b/Etapas/teoria/metodologia/presentacion_cooperadora.pptx
@@ -5538,7 +5538,7 @@
               </a:defRPr>
             </a:pPr>
             <a:r>
-              <a:t>●  ARQUITECTURA DE SOFTWARE</a:t>
+              <a:t>●  PERSISTENCIA HÍBRIDA Y CONCURRENCIA</a:t>
             </a:r>
           </a:p>
         </p:txBody>
@@ -5574,7 +5574,7 @@
               </a:defRPr>
             </a:pPr>
             <a:r>
-              <a:t>Modelo Cliente-Servidor y Persistencia Híbrida</a:t>
+              <a:t>Arquitectura de Datos y Estrategia de Persistencia</a:t>
             </a:r>
           </a:p>
         </p:txBody>
@@ -5702,8 +5702,8 @@
         </p:nvSpPr>
         <p:spPr>
           <a:xfrm>
-            <a:off x="731520" y="1737360"/>
-            <a:ext cx="4114800" cy="1097280"/>
+            <a:off x="731520" y="1645920"/>
+            <a:ext cx="4114800" cy="1188720"/>
           </a:xfrm>
           <a:prstGeom prst="roundRect">
             <a:avLst>
@@ -5749,8 +5749,8 @@
         </p:nvSpPr>
         <p:spPr>
           <a:xfrm>
-            <a:off x="914400" y="1920240"/>
-            <a:ext cx="3749039" cy="731520"/>
+            <a:off x="914400" y="1737360"/>
+            <a:ext cx="3749039" cy="1005840"/>
           </a:xfrm>
           <a:prstGeom prst="rect">
             <a:avLst/>
@@ -5764,6 +5764,9 @@
           <a:lstStyle/>
           <a:p>
             <a:pPr>
+              <a:spcAft>
+                <a:spcPts val="200"/>
+              </a:spcAft>
               <a:defRPr sz="1300" b="1">
                 <a:solidFill>
                   <a:srgbClr val="0F172A"/>
@@ -5777,7 +5780,10 @@
           </a:p>
           <a:p>
             <a:pPr>
-              <a:defRPr sz="1000" b="1">
+              <a:spcAft>
+                <a:spcPts val="400"/>
+              </a:spcAft>
+              <a:defRPr sz="950" b="1">
                 <a:solidFill>
                   <a:srgbClr val="059669"/>
                 </a:solidFill>
@@ -5786,6 +5792,19 @@
             </a:pPr>
             <a:r>
               <a:t>React.js  ·  Vite  ·  Tailwind CSS</a:t>
+            </a:r>
+          </a:p>
+          <a:p>
+            <a:pPr>
+              <a:defRPr sz="850">
+                <a:solidFill>
+                  <a:srgbClr val="475569"/>
+                </a:solidFill>
+                <a:latin typeface="Inter"/>
+              </a:defRPr>
+            </a:pPr>
+            <a:r>
+              <a:t>SPA responsiva cargada dinámicamente. Desacoplada del servidor para escalabilidad e independencia.</a:t>
             </a:r>
           </a:p>
         </p:txBody>
@@ -5799,7 +5818,7 @@
         <p:spPr>
           <a:xfrm>
             <a:off x="731520" y="2834640"/>
-            <a:ext cx="4114800" cy="457200"/>
+            <a:ext cx="4114800" cy="365760"/>
           </a:xfrm>
           <a:prstGeom prst="rect">
             <a:avLst/>
@@ -5813,7 +5832,7 @@
           <a:lstStyle/>
           <a:p>
             <a:pPr algn="ctr">
-              <a:defRPr sz="1100" b="1">
+              <a:defRPr sz="1050" b="1">
                 <a:solidFill>
                   <a:srgbClr val="475569"/>
                 </a:solidFill>
@@ -5834,8 +5853,8 @@
         </p:nvSpPr>
         <p:spPr>
           <a:xfrm>
-            <a:off x="731520" y="3291840"/>
-            <a:ext cx="4114800" cy="1097280"/>
+            <a:off x="731520" y="3200400"/>
+            <a:ext cx="4114800" cy="1188720"/>
           </a:xfrm>
           <a:prstGeom prst="roundRect">
             <a:avLst>
@@ -5881,8 +5900,8 @@
         </p:nvSpPr>
         <p:spPr>
           <a:xfrm>
-            <a:off x="914400" y="3474720"/>
-            <a:ext cx="3749039" cy="731520"/>
+            <a:off x="914400" y="3291840"/>
+            <a:ext cx="3749039" cy="1005840"/>
           </a:xfrm>
           <a:prstGeom prst="rect">
             <a:avLst/>
@@ -5896,6 +5915,9 @@
           <a:lstStyle/>
           <a:p>
             <a:pPr>
+              <a:spcAft>
+                <a:spcPts val="200"/>
+              </a:spcAft>
               <a:defRPr sz="1300" b="1">
                 <a:solidFill>
                   <a:srgbClr val="0F172A"/>
@@ -5909,7 +5931,10 @@
           </a:p>
           <a:p>
             <a:pPr>
-              <a:defRPr sz="1000" b="1">
+              <a:spcAft>
+                <a:spcPts val="400"/>
+              </a:spcAft>
+              <a:defRPr sz="950" b="1">
                 <a:solidFill>
                   <a:srgbClr val="DC2626"/>
                 </a:solidFill>
@@ -5918,6 +5943,19 @@
             </a:pPr>
             <a:r>
               <a:t>Node.js  ·  Express  ·  pnpm workspaces</a:t>
+            </a:r>
+          </a:p>
+          <a:p>
+            <a:pPr>
+              <a:defRPr sz="850">
+                <a:solidFill>
+                  <a:srgbClr val="475569"/>
+                </a:solidFill>
+                <a:latin typeface="Inter"/>
+              </a:defRPr>
+            </a:pPr>
+            <a:r>
+              <a:t>Capa lógica central. Realiza el Data Mashup, gestiona el estado de caché en memoria y controla la concurrencia.</a:t>
             </a:r>
           </a:p>
         </p:txBody>
@@ -5930,8 +5968,8 @@
         </p:nvSpPr>
         <p:spPr>
           <a:xfrm>
-            <a:off x="5303520" y="1737360"/>
-            <a:ext cx="2926080" cy="2011680"/>
+            <a:off x="5303520" y="1645920"/>
+            <a:ext cx="2926080" cy="2194560"/>
           </a:xfrm>
           <a:prstGeom prst="roundRect">
             <a:avLst>
@@ -5977,8 +6015,8 @@
         </p:nvSpPr>
         <p:spPr>
           <a:xfrm>
-            <a:off x="5486400" y="1920240"/>
-            <a:ext cx="2560320" cy="1645920"/>
+            <a:off x="5440680" y="1783080"/>
+            <a:ext cx="2651760" cy="1920240"/>
           </a:xfrm>
           <a:prstGeom prst="rect">
             <a:avLst/>
@@ -5992,26 +6030,39 @@
           <a:lstStyle/>
           <a:p>
             <a:pPr>
+              <a:defRPr sz="1150" b="1">
+                <a:solidFill>
+                  <a:srgbClr val="0F172A"/>
+                </a:solidFill>
+                <a:latin typeface="Montserrat"/>
+              </a:defRPr>
+            </a:pPr>
+            <a:r>
+              <a:t>SQL (Transaccional ACID)</a:t>
+            </a:r>
+          </a:p>
+          <a:p>
+            <a:pPr>
               <a:spcAft>
-                <a:spcPts val="800"/>
+                <a:spcPts val="600"/>
               </a:spcAft>
-              <a:defRPr sz="1200" b="1">
-                <a:solidFill>
-                  <a:srgbClr val="0F172A"/>
-                </a:solidFill>
-                <a:latin typeface="Montserrat"/>
-              </a:defRPr>
-            </a:pPr>
-            <a:r>
-              <a:t>SQL (Transaccional ACID)</a:t>
+              <a:defRPr sz="750" b="1">
+                <a:solidFill>
+                  <a:srgbClr val="059669"/>
+                </a:solidFill>
+                <a:latin typeface="Inter"/>
+              </a:defRPr>
+            </a:pPr>
+            <a:r>
+              <a:t>CONSISTENCIA FINANCIERA</a:t>
             </a:r>
           </a:p>
           <a:p>
             <a:pPr>
               <a:spcAft>
-                <a:spcPts val="400"/>
+                <a:spcPts val="300"/>
               </a:spcAft>
-              <a:defRPr sz="900">
+              <a:defRPr sz="850">
                 <a:solidFill>
                   <a:srgbClr val="475569"/>
                 </a:solidFill>
@@ -6019,15 +6070,15 @@
               </a:defRPr>
             </a:pPr>
             <a:r>
-              <a:t>• usuarios: claves bcryptjs</a:t>
+              <a:t>• usuarios: Claves cifradas (bcryptjs)</a:t>
             </a:r>
           </a:p>
           <a:p>
             <a:pPr>
               <a:spcAft>
-                <a:spcPts val="400"/>
+                <a:spcPts val="300"/>
               </a:spcAft>
-              <a:defRPr sz="900">
+              <a:defRPr sz="850">
                 <a:solidFill>
                   <a:srgbClr val="475569"/>
                 </a:solidFill>
@@ -6035,15 +6086,15 @@
               </a:defRPr>
             </a:pPr>
             <a:r>
-              <a:t>• perfiles_socios: datos DNI</a:t>
+              <a:t>• perfiles_socios: Libro social (DNI único)</a:t>
             </a:r>
           </a:p>
           <a:p>
             <a:pPr>
               <a:spcAft>
-                <a:spcPts val="400"/>
+                <a:spcPts val="300"/>
               </a:spcAft>
-              <a:defRPr sz="900">
+              <a:defRPr sz="850">
                 <a:solidFill>
                   <a:srgbClr val="475569"/>
                 </a:solidFill>
@@ -6051,7 +6102,23 @@
               </a:defRPr>
             </a:pPr>
             <a:r>
-              <a:t>• campanas_eco: balances</a:t>
+              <a:t>• campanas_eco: Balances y metas</a:t>
+            </a:r>
+          </a:p>
+          <a:p>
+            <a:pPr>
+              <a:spcBef>
+                <a:spcPts val="600"/>
+              </a:spcBef>
+              <a:defRPr sz="800" i="1">
+                <a:solidFill>
+                  <a:srgbClr val="475569"/>
+                </a:solidFill>
+                <a:latin typeface="Inter"/>
+              </a:defRPr>
+            </a:pPr>
+            <a:r>
+              <a:t>Justificación: Datos que exigen atomicidad, consistencia, aislamiento y durabilidad relacional.</a:t>
             </a:r>
           </a:p>
         </p:txBody>
@@ -6064,8 +6131,8 @@
         </p:nvSpPr>
         <p:spPr>
           <a:xfrm>
-            <a:off x="8503920" y="1737360"/>
-            <a:ext cx="2926080" cy="2011680"/>
+            <a:off x="8503920" y="1645920"/>
+            <a:ext cx="2926080" cy="2194560"/>
           </a:xfrm>
           <a:prstGeom prst="roundRect">
             <a:avLst>
@@ -6111,8 +6178,8 @@
         </p:nvSpPr>
         <p:spPr>
           <a:xfrm>
-            <a:off x="8686800" y="1920240"/>
-            <a:ext cx="2560320" cy="1645920"/>
+            <a:off x="8641080" y="1783080"/>
+            <a:ext cx="2651760" cy="1920240"/>
           </a:xfrm>
           <a:prstGeom prst="rect">
             <a:avLst/>
@@ -6126,26 +6193,39 @@
           <a:lstStyle/>
           <a:p>
             <a:pPr>
+              <a:defRPr sz="1150" b="1">
+                <a:solidFill>
+                  <a:srgbClr val="0F172A"/>
+                </a:solidFill>
+                <a:latin typeface="Montserrat"/>
+              </a:defRPr>
+            </a:pPr>
+            <a:r>
+              <a:t>NoSQL (Documental)</a:t>
+            </a:r>
+          </a:p>
+          <a:p>
+            <a:pPr>
               <a:spcAft>
-                <a:spcPts val="800"/>
+                <a:spcPts val="600"/>
               </a:spcAft>
-              <a:defRPr sz="1200" b="1">
-                <a:solidFill>
-                  <a:srgbClr val="0F172A"/>
-                </a:solidFill>
-                <a:latin typeface="Montserrat"/>
-              </a:defRPr>
-            </a:pPr>
-            <a:r>
-              <a:t>NoSQL (Documental Flexible)</a:t>
+              <a:defRPr sz="750" b="1">
+                <a:solidFill>
+                  <a:srgbClr val="DC2626"/>
+                </a:solidFill>
+                <a:latin typeface="Inter"/>
+              </a:defRPr>
+            </a:pPr>
+            <a:r>
+              <a:t>FLEXIBILIDAD Y MULTIMEDIA</a:t>
             </a:r>
           </a:p>
           <a:p>
             <a:pPr>
               <a:spcAft>
-                <a:spcPts val="400"/>
+                <a:spcPts val="300"/>
               </a:spcAft>
-              <a:defRPr sz="900">
+              <a:defRPr sz="850">
                 <a:solidFill>
                   <a:srgbClr val="475569"/>
                 </a:solidFill>
@@ -6153,15 +6233,15 @@
               </a:defRPr>
             </a:pPr>
             <a:r>
-              <a:t>• noticias_actualidad: galerías</a:t>
+              <a:t>• noticias_actualidad: Novedades multimedia</a:t>
             </a:r>
           </a:p>
           <a:p>
             <a:pPr>
               <a:spcAft>
-                <a:spcPts val="400"/>
+                <a:spcPts val="300"/>
               </a:spcAft>
-              <a:defRPr sz="900">
+              <a:defRPr sz="850">
                 <a:solidFill>
                   <a:srgbClr val="475569"/>
                 </a:solidFill>
@@ -6169,15 +6249,15 @@
               </a:defRPr>
             </a:pPr>
             <a:r>
-              <a:t>• campanas_detalle: multimedia</a:t>
+              <a:t>• campanas_detalle: Historias de obras</a:t>
             </a:r>
           </a:p>
           <a:p>
             <a:pPr>
               <a:spcAft>
-                <a:spcPts val="400"/>
+                <a:spcPts val="300"/>
               </a:spcAft>
-              <a:defRPr sz="900">
+              <a:defRPr sz="850">
                 <a:solidFill>
                   <a:srgbClr val="475569"/>
                 </a:solidFill>
@@ -6185,7 +6265,23 @@
               </a:defRPr>
             </a:pPr>
             <a:r>
-              <a:t>  enlazado por campana_id_ref</a:t>
+              <a:t>  Enlazado por campana_id_ref</a:t>
+            </a:r>
+          </a:p>
+          <a:p>
+            <a:pPr>
+              <a:spcBef>
+                <a:spcPts val="600"/>
+              </a:spcBef>
+              <a:defRPr sz="800" i="1">
+                <a:solidFill>
+                  <a:srgbClr val="475569"/>
+                </a:solidFill>
+                <a:latin typeface="Inter"/>
+              </a:defRPr>
+            </a:pPr>
+            <a:r>
+              <a:t>Justificación: Formatos dinámicos sin esquemas rígidos, ideal para galerías y logs de noticias.</a:t>
             </a:r>
           </a:p>
         </p:txBody>
@@ -6199,7 +6295,7 @@
         <p:spPr>
           <a:xfrm>
             <a:off x="5303520" y="3931920"/>
-            <a:ext cx="6126480" cy="1920240"/>
+            <a:ext cx="6126480" cy="2011680"/>
           </a:xfrm>
           <a:prstGeom prst="roundRect">
             <a:avLst>
@@ -6245,8 +6341,8 @@
         </p:nvSpPr>
         <p:spPr>
           <a:xfrm>
-            <a:off x="5486400" y="4114800"/>
-            <a:ext cx="5760720" cy="1554480"/>
+            <a:off x="5486400" y="4069080"/>
+            <a:ext cx="5760720" cy="1737360"/>
           </a:xfrm>
           <a:prstGeom prst="rect">
             <a:avLst/>
@@ -6271,7 +6367,7 @@
               </a:defRPr>
             </a:pPr>
             <a:r>
-              <a:t>MECANISMOS AVANZADOS DE DATOS:</a:t>
+              <a:t>TEMAS CLAVE DE EXPOSICIÓN (DEFENSA TFI):</a:t>
             </a:r>
           </a:p>
           <a:p>
@@ -6279,7 +6375,7 @@
               <a:spcAft>
                 <a:spcPts val="600"/>
               </a:spcAft>
-              <a:defRPr sz="1000" b="1">
+              <a:defRPr sz="900" b="1">
                 <a:solidFill>
                   <a:srgbClr val="DC2626"/>
                 </a:solidFill>
@@ -6287,20 +6383,23 @@
               </a:defRPr>
             </a:pPr>
             <a:r>
-              <a:t>⚡  Data Mashup Sincrónico: </a:t>
-            </a:r>
-            <a:r>
-              <a:rPr b="0">
+              <a:t>⚡  1. Data Mashup Sincrónico (Optimización de Latencia): </a:t>
+            </a:r>
+            <a:r>
+              <a:rPr b="0" sz="850">
                 <a:solidFill>
                   <a:srgbClr val="475569"/>
                 </a:solidFill>
               </a:rPr>
-              <a:t>Las consultas a SQL (finanzas) y NoSQL (multimedia) se ejecutan en paralelo con Promise.all y se unifican en un JSON plano enviado al cliente.</a:t>
-            </a:r>
-          </a:p>
-          <a:p>
-            <a:pPr>
-              <a:defRPr sz="1000" b="1">
+              <a:t>Para acelerar la red, el backend consulta Sequelize y Mongoose en paralelo usando Promise.all() y los unifica en un JSON plano antes de enviarlo al cliente.</a:t>
+            </a:r>
+          </a:p>
+          <a:p>
+            <a:pPr>
+              <a:spcAft>
+                <a:spcPts val="200"/>
+              </a:spcAft>
+              <a:defRPr sz="900" b="1">
                 <a:solidFill>
                   <a:srgbClr val="DC2626"/>
                 </a:solidFill>
@@ -6308,15 +6407,15 @@
               </a:defRPr>
             </a:pPr>
             <a:r>
-              <a:t>⚡  Evitación de Condiciones de Carrera: </a:t>
-            </a:r>
-            <a:r>
-              <a:rPr b="0">
+              <a:t>⚡  2. Control de Concurrencia Relacional (Integridad Financiera): </a:t>
+            </a:r>
+            <a:r>
+              <a:rPr b="0" sz="850">
                 <a:solidFill>
                   <a:srgbClr val="475569"/>
                 </a:solidFill>
               </a:rPr>
-              <a:t>Las donaciones concurrentes bloquean la fila financiera en SQL (SELECT ... FOR UPDATE) garantizando consistencia y transaccionalidad ACID.</a:t>
+              <a:t>Al donar concurrentemente, se abre una transacción SQL que adquiere un bloqueo exclusivo de fila (SELECT ... FOR UPDATE), encolando otros hilos y evitando cálculos inconsistentes del balance.</a:t>
             </a:r>
           </a:p>
         </p:txBody>

</xml_diff>

<commit_message>
docs: sync TFI presentation files with TRABAJO_METODOLOGIA_ORIGINAL.md
</commit_message>
<xml_diff>
--- a/Etapas/teoria/metodologia/presentacion_cooperadora.pptx
+++ b/Etapas/teoria/metodologia/presentacion_cooperadora.pptx
@@ -7182,12 +7182,12 @@
         </p:nvSpPr>
         <p:spPr>
           <a:xfrm>
-            <a:off x="731520" y="1737360"/>
-            <a:ext cx="3328416" cy="4114800"/>
+            <a:off x="731520" y="1645920"/>
+            <a:ext cx="5120640" cy="2011680"/>
           </a:xfrm>
           <a:prstGeom prst="roundRect">
             <a:avLst>
-              <a:gd name="adj" fmla="val 6000"/>
+              <a:gd name="adj" fmla="val 5000"/>
             </a:avLst>
           </a:prstGeom>
           <a:solidFill>
@@ -7229,8 +7229,8 @@
         </p:nvSpPr>
         <p:spPr>
           <a:xfrm>
-            <a:off x="914400" y="2011680"/>
-            <a:ext cx="2962656" cy="3657600"/>
+            <a:off x="868680" y="1783080"/>
+            <a:ext cx="4846320" cy="1737360"/>
           </a:xfrm>
           <a:prstGeom prst="rect">
             <a:avLst/>
@@ -7244,7 +7244,7 @@
           <a:lstStyle/>
           <a:p>
             <a:pPr>
-              <a:defRPr sz="1300" b="1">
+              <a:defRPr sz="1100" b="1">
                 <a:solidFill>
                   <a:srgbClr val="059669"/>
                 </a:solidFill>
@@ -7252,15 +7252,15 @@
               </a:defRPr>
             </a:pPr>
             <a:r>
-              <a:t>Singleton Pattern</a:t>
+              <a:t>Abstracción e Interfaz</a:t>
             </a:r>
           </a:p>
           <a:p>
             <a:pPr>
               <a:spcAft>
-                <a:spcPts val="1200"/>
+                <a:spcPts val="600"/>
               </a:spcAft>
-              <a:defRPr sz="950" b="1">
+              <a:defRPr sz="850" b="1">
                 <a:solidFill>
                   <a:srgbClr val="DC2626"/>
                 </a:solidFill>
@@ -7268,15 +7268,15 @@
               </a:defRPr>
             </a:pPr>
             <a:r>
-              <a:t>CONEXIÓN DE BD ÚNICA</a:t>
+              <a:t>PASARELA DE PAGOS GENÉRICA</a:t>
             </a:r>
           </a:p>
           <a:p>
             <a:pPr>
               <a:lnSpc>
-                <a:spcPct val="125000"/>
+                <a:spcPct val="115000"/>
               </a:lnSpc>
-              <a:defRPr sz="900">
+              <a:defRPr sz="819">
                 <a:solidFill>
                   <a:srgbClr val="475569"/>
                 </a:solidFill>
@@ -7284,16 +7284,19 @@
               </a:defRPr>
             </a:pPr>
             <a:r>
-              <a:t>Módulo: config/db.js</a:t>
+              <a:t>Módulo: socioSubscriptionController.js y mpService.js (Cuotas transaccionales)</a:t>
             </a:r>
             <a:br/>
             <a:r>
-              <a:t>Asegura que toda la aplicación de Express comparta una única instancia de conexión para los motores SQL y NoSQL.</a:t>
+              <a:t>Solución: Crear un contrato abstracto IPaymentGateway con firmas abstractas (procesarPagoRecurrente, cancelarSuscripcion) para desacoplar el SDK directo de Mercado Pago.</a:t>
             </a:r>
             <a:br/>
+            <a:r>
+              <a:t>Ventaja: Desacoplamiento de infraestructura. Migra a Stripe/MODO sin tocar controladores.</a:t>
+            </a:r>
             <a:br/>
             <a:r>
-              <a:t>Ventaja: Ahorro de memoria, previene la sobrecarga del pool de conexiones al evitar múltiples instancias redundantes.</a:t>
+              <a:t>Desventaja: JS no tiene interfaces nativas; debe emularse manualmente en runtime.</a:t>
             </a:r>
           </a:p>
         </p:txBody>
@@ -7306,12 +7309,12 @@
         </p:nvSpPr>
         <p:spPr>
           <a:xfrm>
-            <a:off x="4425696" y="1737360"/>
-            <a:ext cx="3328416" cy="4114800"/>
+            <a:off x="6217920" y="1645920"/>
+            <a:ext cx="5120640" cy="2011680"/>
           </a:xfrm>
           <a:prstGeom prst="roundRect">
             <a:avLst>
-              <a:gd name="adj" fmla="val 6000"/>
+              <a:gd name="adj" fmla="val 5000"/>
             </a:avLst>
           </a:prstGeom>
           <a:solidFill>
@@ -7353,8 +7356,8 @@
         </p:nvSpPr>
         <p:spPr>
           <a:xfrm>
-            <a:off x="4608576" y="2011680"/>
-            <a:ext cx="2962656" cy="3657600"/>
+            <a:off x="6355080" y="1783080"/>
+            <a:ext cx="4846320" cy="1737360"/>
           </a:xfrm>
           <a:prstGeom prst="rect">
             <a:avLst/>
@@ -7368,7 +7371,7 @@
           <a:lstStyle/>
           <a:p>
             <a:pPr>
-              <a:defRPr sz="1300" b="1">
+              <a:defRPr sz="1100" b="1">
                 <a:solidFill>
                   <a:srgbClr val="059669"/>
                 </a:solidFill>
@@ -7382,9 +7385,9 @@
           <a:p>
             <a:pPr>
               <a:spcAft>
-                <a:spcPts val="1200"/>
+                <a:spcPts val="600"/>
               </a:spcAft>
-              <a:defRPr sz="950" b="1">
+              <a:defRPr sz="850" b="1">
                 <a:solidFill>
                   <a:srgbClr val="DC2626"/>
                 </a:solidFill>
@@ -7398,9 +7401,9 @@
           <a:p>
             <a:pPr>
               <a:lnSpc>
-                <a:spcPct val="125000"/>
+                <a:spcPct val="115000"/>
               </a:lnSpc>
-              <a:defRPr sz="900">
+              <a:defRPr sz="819">
                 <a:solidFill>
                   <a:srgbClr val="475569"/>
                 </a:solidFill>
@@ -7408,16 +7411,19 @@
               </a:defRPr>
             </a:pPr>
             <a:r>
-              <a:t>Módulo: services/userService.js</a:t>
+              <a:t>Módulo: services/userService.js (Creación de cuentas)</a:t>
             </a:r>
             <a:br/>
             <a:r>
-              <a:t>Delegación de la creación de instancias del modelo según rol (Socio o Admin), precargando permisos específicos.</a:t>
+              <a:t>Solución: Utilizar una fábrica que, dado el rol (Socio o Admin), instancie la clase correcta del modelo cargando sus respectivos permisos iniciales.</a:t>
             </a:r>
             <a:br/>
+            <a:r>
+              <a:t>Ventaja: Desacopla la creación de objetos y cumple Open/Closed al agregar roles.</a:t>
+            </a:r>
             <a:br/>
             <a:r>
-              <a:t>Ventaja: Cumple con el principio Open/Closed al poder añadir nuevos roles fácilmente sin alterar controladores.</a:t>
+              <a:t>Desventaja: Puede ser sobreingeniería si la estructura de roles es fija.</a:t>
             </a:r>
           </a:p>
         </p:txBody>
@@ -7430,12 +7436,12 @@
         </p:nvSpPr>
         <p:spPr>
           <a:xfrm>
-            <a:off x="8119872" y="1737360"/>
-            <a:ext cx="3328416" cy="4114800"/>
+            <a:off x="731520" y="3931920"/>
+            <a:ext cx="5120640" cy="2011680"/>
           </a:xfrm>
           <a:prstGeom prst="roundRect">
             <a:avLst>
-              <a:gd name="adj" fmla="val 6000"/>
+              <a:gd name="adj" fmla="val 5000"/>
             </a:avLst>
           </a:prstGeom>
           <a:solidFill>
@@ -7477,8 +7483,8 @@
         </p:nvSpPr>
         <p:spPr>
           <a:xfrm>
-            <a:off x="8302752" y="2011680"/>
-            <a:ext cx="2962656" cy="3657600"/>
+            <a:off x="868680" y="4069080"/>
+            <a:ext cx="4846320" cy="1737360"/>
           </a:xfrm>
           <a:prstGeom prst="rect">
             <a:avLst/>
@@ -7492,7 +7498,7 @@
           <a:lstStyle/>
           <a:p>
             <a:pPr>
-              <a:defRPr sz="1300" b="1">
+              <a:defRPr sz="1100" b="1">
                 <a:solidFill>
                   <a:srgbClr val="059669"/>
                 </a:solidFill>
@@ -7500,15 +7506,142 @@
               </a:defRPr>
             </a:pPr>
             <a:r>
+              <a:t>Singleton Pattern</a:t>
+            </a:r>
+          </a:p>
+          <a:p>
+            <a:pPr>
+              <a:spcAft>
+                <a:spcPts val="600"/>
+              </a:spcAft>
+              <a:defRPr sz="850" b="1">
+                <a:solidFill>
+                  <a:srgbClr val="DC2626"/>
+                </a:solidFill>
+                <a:latin typeface="Montserrat"/>
+              </a:defRPr>
+            </a:pPr>
+            <a:r>
+              <a:t>CONEXIÓN DE BD ÚNICA</a:t>
+            </a:r>
+          </a:p>
+          <a:p>
+            <a:pPr>
+              <a:lnSpc>
+                <a:spcPct val="115000"/>
+              </a:lnSpc>
+              <a:defRPr sz="819">
+                <a:solidFill>
+                  <a:srgbClr val="475569"/>
+                </a:solidFill>
+                <a:latin typeface="Inter"/>
+              </a:defRPr>
+            </a:pPr>
+            <a:r>
+              <a:t>Módulo: config/db.js (Conexiones PostgreSQL y MongoDB)</a:t>
+            </a:r>
+            <a:br/>
+            <a:r>
+              <a:t>Solución: Implementar Singleton para asegurar que toda la aplicación comparta y reutilice una única instancia activa de conexión para ambos motores de base de datos.</a:t>
+            </a:r>
+            <a:br/>
+            <a:r>
+              <a:t>Ventaja: Optimización y ahorro de memoria, previene la sobrecarga del pool.</a:t>
+            </a:r>
+            <a:br/>
+            <a:r>
+              <a:t>Desventaja: Introduce estado global en la app, dificultando mocks en tests unitarios.</a:t>
+            </a:r>
+          </a:p>
+        </p:txBody>
+      </p:sp>
+      <p:sp>
+        <p:nvSpPr>
+          <p:cNvPr id="13" name="Rounded Rectangle 12"/>
+          <p:cNvSpPr/>
+          <p:nvPr/>
+        </p:nvSpPr>
+        <p:spPr>
+          <a:xfrm>
+            <a:off x="6217920" y="3931920"/>
+            <a:ext cx="5120640" cy="2011680"/>
+          </a:xfrm>
+          <a:prstGeom prst="roundRect">
+            <a:avLst>
+              <a:gd name="adj" fmla="val 5000"/>
+            </a:avLst>
+          </a:prstGeom>
+          <a:solidFill>
+            <a:srgbClr val="FFFFFF"/>
+          </a:solidFill>
+          <a:ln w="19050">
+            <a:solidFill>
+              <a:srgbClr val="E2E8F0"/>
+            </a:solidFill>
+          </a:ln>
+        </p:spPr>
+        <p:style>
+          <a:lnRef idx="1">
+            <a:schemeClr val="accent1"/>
+          </a:lnRef>
+          <a:fillRef idx="3">
+            <a:schemeClr val="accent1"/>
+          </a:fillRef>
+          <a:effectRef idx="2">
+            <a:schemeClr val="accent1"/>
+          </a:effectRef>
+          <a:fontRef idx="minor">
+            <a:schemeClr val="lt1"/>
+          </a:fontRef>
+        </p:style>
+        <p:txBody>
+          <a:bodyPr rtlCol="0" anchor="ctr"/>
+          <a:lstStyle/>
+          <a:p>
+            <a:pPr algn="ctr"/>
+          </a:p>
+        </p:txBody>
+      </p:sp>
+      <p:sp>
+        <p:nvSpPr>
+          <p:cNvPr id="14" name="TextBox 13"/>
+          <p:cNvSpPr txBox="1"/>
+          <p:nvPr/>
+        </p:nvSpPr>
+        <p:spPr>
+          <a:xfrm>
+            <a:off x="6355080" y="4069080"/>
+            <a:ext cx="4846320" cy="1737360"/>
+          </a:xfrm>
+          <a:prstGeom prst="rect">
+            <a:avLst/>
+          </a:prstGeom>
+          <a:noFill/>
+        </p:spPr>
+        <p:txBody>
+          <a:bodyPr wrap="square" lIns="0" tIns="0" rIns="0" bIns="0">
+            <a:spAutoFit/>
+          </a:bodyPr>
+          <a:lstStyle/>
+          <a:p>
+            <a:pPr>
+              <a:defRPr sz="1100" b="1">
+                <a:solidFill>
+                  <a:srgbClr val="059669"/>
+                </a:solidFill>
+                <a:latin typeface="Montserrat"/>
+              </a:defRPr>
+            </a:pPr>
+            <a:r>
               <a:t>State Pattern + Async Worker</a:t>
             </a:r>
           </a:p>
           <a:p>
             <a:pPr>
               <a:spcAft>
-                <a:spcPts val="1200"/>
+                <a:spcPts val="600"/>
               </a:spcAft>
-              <a:defRPr sz="950" b="1">
+              <a:defRPr sz="850" b="1">
                 <a:solidFill>
                   <a:srgbClr val="DC2626"/>
                 </a:solidFill>
@@ -7516,15 +7649,15 @@
               </a:defRPr>
             </a:pPr>
             <a:r>
-              <a:t>CONCILIACIÓN AUTOMÁTICA</a:t>
+              <a:t>CONCILIACIÓN DE TRANSFERENCIAS</a:t>
             </a:r>
           </a:p>
           <a:p>
             <a:pPr>
               <a:lnSpc>
-                <a:spcPct val="125000"/>
+                <a:spcPct val="115000"/>
               </a:lnSpc>
-              <a:defRPr sz="900">
+              <a:defRPr sz="819">
                 <a:solidFill>
                   <a:srgbClr val="475569"/>
                 </a:solidFill>
@@ -7532,16 +7665,19 @@
               </a:defRPr>
             </a:pPr>
             <a:r>
-              <a:t>Módulo: donacionController.js</a:t>
+              <a:t>Módulo: donacionController.js (Validación de transferencias bancarias)</a:t>
             </a:r>
             <a:br/>
             <a:r>
-              <a:t>Flujo de transferencias manuales dividido en clases de estado (EstadoPendiente, EstadoAprobado, EstadoRechazado) con un Cron Job / Worker de conciliación automática en segundo plano.</a:t>
+              <a:t>Solución: Delegar flujos de transferencias a clases de estado (EstadoPendiente, EstadoAprobado, EstadoRechazado) con un Worker/Cron en segundo plano de conciliación asíncrona.</a:t>
             </a:r>
             <a:br/>
+            <a:r>
+              <a:t>Ventaja: Rompe el cuello de botella manual; barra de progreso en tiempo real y correos inmediatos.</a:t>
+            </a:r>
             <a:br/>
             <a:r>
-              <a:t>Ventaja: Resuelve el cuello de botella manual.</a:t>
+              <a:t>Desventaja: Mayor complejidad técnica por cron o colas de tareas.</a:t>
             </a:r>
           </a:p>
         </p:txBody>

</xml_diff>